<commit_message>
Update opening PPT v4 materials
</commit_message>
<xml_diff>
--- a/docs/opening/opening_ppt_template_version_v3.pptx
+++ b/docs/opening/opening_ppt_template_version_v3.pptx
@@ -61,7 +61,7 @@
         <a:solidFill>
           <a:srgbClr val="FF3300"/>
         </a:solidFill>
-        <a:latin typeface="Arial" panose="020B0604020202020204" pitchFamily="34" charset="0"/>
+        <a:latin typeface="Arial" panose="020B0604020202090204" pitchFamily="34" charset="0"/>
         <a:ea typeface="黑体" panose="02010609060101010101" pitchFamily="49" charset="-122"/>
         <a:cs typeface="+mn-cs"/>
       </a:defRPr>
@@ -81,7 +81,7 @@
         <a:solidFill>
           <a:srgbClr val="FF3300"/>
         </a:solidFill>
-        <a:latin typeface="Arial" panose="020B0604020202020204" pitchFamily="34" charset="0"/>
+        <a:latin typeface="Arial" panose="020B0604020202090204" pitchFamily="34" charset="0"/>
         <a:ea typeface="黑体" panose="02010609060101010101" pitchFamily="49" charset="-122"/>
         <a:cs typeface="+mn-cs"/>
       </a:defRPr>
@@ -101,7 +101,7 @@
         <a:solidFill>
           <a:srgbClr val="FF3300"/>
         </a:solidFill>
-        <a:latin typeface="Arial" panose="020B0604020202020204" pitchFamily="34" charset="0"/>
+        <a:latin typeface="Arial" panose="020B0604020202090204" pitchFamily="34" charset="0"/>
         <a:ea typeface="黑体" panose="02010609060101010101" pitchFamily="49" charset="-122"/>
         <a:cs typeface="+mn-cs"/>
       </a:defRPr>
@@ -121,7 +121,7 @@
         <a:solidFill>
           <a:srgbClr val="FF3300"/>
         </a:solidFill>
-        <a:latin typeface="Arial" panose="020B0604020202020204" pitchFamily="34" charset="0"/>
+        <a:latin typeface="Arial" panose="020B0604020202090204" pitchFamily="34" charset="0"/>
         <a:ea typeface="黑体" panose="02010609060101010101" pitchFamily="49" charset="-122"/>
         <a:cs typeface="+mn-cs"/>
       </a:defRPr>
@@ -141,7 +141,7 @@
         <a:solidFill>
           <a:srgbClr val="FF3300"/>
         </a:solidFill>
-        <a:latin typeface="Arial" panose="020B0604020202020204" pitchFamily="34" charset="0"/>
+        <a:latin typeface="Arial" panose="020B0604020202090204" pitchFamily="34" charset="0"/>
         <a:ea typeface="黑体" panose="02010609060101010101" pitchFamily="49" charset="-122"/>
         <a:cs typeface="+mn-cs"/>
       </a:defRPr>
@@ -161,7 +161,7 @@
         <a:solidFill>
           <a:srgbClr val="FF3300"/>
         </a:solidFill>
-        <a:latin typeface="Arial" panose="020B0604020202020204" pitchFamily="34" charset="0"/>
+        <a:latin typeface="Arial" panose="020B0604020202090204" pitchFamily="34" charset="0"/>
         <a:ea typeface="黑体" panose="02010609060101010101" pitchFamily="49" charset="-122"/>
         <a:cs typeface="+mn-cs"/>
       </a:defRPr>
@@ -181,7 +181,7 @@
         <a:solidFill>
           <a:srgbClr val="FF3300"/>
         </a:solidFill>
-        <a:latin typeface="Arial" panose="020B0604020202020204" pitchFamily="34" charset="0"/>
+        <a:latin typeface="Arial" panose="020B0604020202090204" pitchFamily="34" charset="0"/>
         <a:ea typeface="黑体" panose="02010609060101010101" pitchFamily="49" charset="-122"/>
         <a:cs typeface="+mn-cs"/>
       </a:defRPr>
@@ -201,7 +201,7 @@
         <a:solidFill>
           <a:srgbClr val="FF3300"/>
         </a:solidFill>
-        <a:latin typeface="Arial" panose="020B0604020202020204" pitchFamily="34" charset="0"/>
+        <a:latin typeface="Arial" panose="020B0604020202090204" pitchFamily="34" charset="0"/>
         <a:ea typeface="黑体" panose="02010609060101010101" pitchFamily="49" charset="-122"/>
         <a:cs typeface="+mn-cs"/>
       </a:defRPr>
@@ -221,7 +221,7 @@
         <a:solidFill>
           <a:srgbClr val="FF3300"/>
         </a:solidFill>
-        <a:latin typeface="Arial" panose="020B0604020202020204" pitchFamily="34" charset="0"/>
+        <a:latin typeface="Arial" panose="020B0604020202090204" pitchFamily="34" charset="0"/>
         <a:ea typeface="黑体" panose="02010609060101010101" pitchFamily="49" charset="-122"/>
         <a:cs typeface="+mn-cs"/>
       </a:defRPr>
@@ -235,7 +235,7 @@
             <a:srgbClr val="A4A3A4"/>
           </p15:clr>
         </p15:guide>
-        <p15:guide id="2" pos="2898" userDrawn="1">
+        <p15:guide id="2" pos="2880" userDrawn="1">
           <p15:clr>
             <a:srgbClr val="A4A3A4"/>
           </p15:clr>
@@ -341,7 +341,7 @@
                 <a:solidFill>
                   <a:schemeClr val="tx1"/>
                 </a:solidFill>
-                <a:ea typeface="宋体" panose="02010600030101010101" pitchFamily="2" charset="-122"/>
+                <a:ea typeface="宋体" pitchFamily="2" charset="-122"/>
               </a:defRPr>
             </a:lvl1pPr>
           </a:lstStyle>
@@ -372,8 +372,8 @@
               <a:effectLst/>
               <a:uLnTx/>
               <a:uFillTx/>
-              <a:latin typeface="Arial" panose="020B0604020202020204" pitchFamily="34" charset="0"/>
-              <a:ea typeface="宋体" panose="02010600030101010101" pitchFamily="2" charset="-122"/>
+              <a:latin typeface="Arial" panose="020B0604020202090204" pitchFamily="34" charset="0"/>
+              <a:ea typeface="宋体" pitchFamily="2" charset="-122"/>
               <a:cs typeface="+mn-cs"/>
             </a:endParaRPr>
           </a:p>
@@ -449,7 +449,7 @@
                 <a:solidFill>
                   <a:schemeClr val="tx1"/>
                 </a:solidFill>
-                <a:ea typeface="宋体" panose="02010600030101010101" pitchFamily="2" charset="-122"/>
+                <a:ea typeface="宋体" pitchFamily="2" charset="-122"/>
               </a:defRPr>
             </a:lvl1pPr>
           </a:lstStyle>
@@ -480,8 +480,8 @@
               <a:effectLst/>
               <a:uLnTx/>
               <a:uFillTx/>
-              <a:latin typeface="Arial" panose="020B0604020202020204" pitchFamily="34" charset="0"/>
-              <a:ea typeface="宋体" panose="02010600030101010101" pitchFamily="2" charset="-122"/>
+              <a:latin typeface="Arial" panose="020B0604020202090204" pitchFamily="34" charset="0"/>
+              <a:ea typeface="宋体" pitchFamily="2" charset="-122"/>
               <a:cs typeface="+mn-cs"/>
             </a:endParaRPr>
           </a:p>
@@ -557,7 +557,7 @@
                 <a:solidFill>
                   <a:schemeClr val="tx1"/>
                 </a:solidFill>
-                <a:ea typeface="宋体" panose="02010600030101010101" pitchFamily="2" charset="-122"/>
+                <a:ea typeface="宋体" pitchFamily="2" charset="-122"/>
               </a:defRPr>
             </a:lvl1pPr>
           </a:lstStyle>
@@ -588,8 +588,8 @@
               <a:effectLst/>
               <a:uLnTx/>
               <a:uFillTx/>
-              <a:latin typeface="Arial" panose="020B0604020202020204" pitchFamily="34" charset="0"/>
-              <a:ea typeface="宋体" panose="02010600030101010101" pitchFamily="2" charset="-122"/>
+              <a:latin typeface="Arial" panose="020B0604020202090204" pitchFamily="34" charset="0"/>
+              <a:ea typeface="宋体" pitchFamily="2" charset="-122"/>
               <a:cs typeface="+mn-cs"/>
             </a:endParaRPr>
           </a:p>
@@ -665,7 +665,7 @@
                 <a:solidFill>
                   <a:schemeClr val="tx1"/>
                 </a:solidFill>
-                <a:ea typeface="宋体" panose="02010600030101010101" pitchFamily="2" charset="-122"/>
+                <a:ea typeface="宋体" pitchFamily="2" charset="-122"/>
               </a:defRPr>
             </a:lvl1pPr>
           </a:lstStyle>
@@ -697,8 +697,8 @@
                 <a:effectLst/>
                 <a:uLnTx/>
                 <a:uFillTx/>
-                <a:latin typeface="Arial" panose="020B0604020202020204" pitchFamily="34" charset="0"/>
-                <a:ea typeface="宋体" panose="02010600030101010101" pitchFamily="2" charset="-122"/>
+                <a:latin typeface="Arial" panose="020B0604020202090204" pitchFamily="34" charset="0"/>
+                <a:ea typeface="宋体" pitchFamily="2" charset="-122"/>
                 <a:cs typeface="+mn-cs"/>
               </a:rPr>
             </a:fld>
@@ -712,8 +712,8 @@
               <a:effectLst/>
               <a:uLnTx/>
               <a:uFillTx/>
-              <a:latin typeface="Arial" panose="020B0604020202020204" pitchFamily="34" charset="0"/>
-              <a:ea typeface="宋体" panose="02010600030101010101" pitchFamily="2" charset="-122"/>
+              <a:latin typeface="Arial" panose="020B0604020202090204" pitchFamily="34" charset="0"/>
+              <a:ea typeface="宋体" pitchFamily="2" charset="-122"/>
               <a:cs typeface="+mn-cs"/>
             </a:endParaRPr>
           </a:p>
@@ -820,7 +820,7 @@
                 <a:solidFill>
                   <a:schemeClr val="tx1"/>
                 </a:solidFill>
-                <a:ea typeface="宋体" panose="02010600030101010101" pitchFamily="2" charset="-122"/>
+                <a:ea typeface="宋体" pitchFamily="2" charset="-122"/>
               </a:defRPr>
             </a:lvl1pPr>
           </a:lstStyle>
@@ -851,8 +851,8 @@
               <a:effectLst/>
               <a:uLnTx/>
               <a:uFillTx/>
-              <a:latin typeface="Arial" panose="020B0604020202020204" pitchFamily="34" charset="0"/>
-              <a:ea typeface="宋体" panose="02010600030101010101" pitchFamily="2" charset="-122"/>
+              <a:latin typeface="Arial" panose="020B0604020202090204" pitchFamily="34" charset="0"/>
+              <a:ea typeface="宋体" pitchFamily="2" charset="-122"/>
               <a:cs typeface="+mn-cs"/>
             </a:endParaRPr>
           </a:p>
@@ -928,7 +928,7 @@
                 <a:solidFill>
                   <a:schemeClr val="tx1"/>
                 </a:solidFill>
-                <a:ea typeface="宋体" panose="02010600030101010101" pitchFamily="2" charset="-122"/>
+                <a:ea typeface="宋体" pitchFamily="2" charset="-122"/>
               </a:defRPr>
             </a:lvl1pPr>
           </a:lstStyle>
@@ -959,8 +959,8 @@
               <a:effectLst/>
               <a:uLnTx/>
               <a:uFillTx/>
-              <a:latin typeface="Arial" panose="020B0604020202020204" pitchFamily="34" charset="0"/>
-              <a:ea typeface="宋体" panose="02010600030101010101" pitchFamily="2" charset="-122"/>
+              <a:latin typeface="Arial" panose="020B0604020202090204" pitchFamily="34" charset="0"/>
+              <a:ea typeface="宋体" pitchFamily="2" charset="-122"/>
               <a:cs typeface="+mn-cs"/>
             </a:endParaRPr>
           </a:p>
@@ -1079,8 +1079,8 @@
                 <a:effectLst/>
                 <a:uLnTx/>
                 <a:uFillTx/>
-                <a:latin typeface="Arial" panose="020B0604020202020204" pitchFamily="34" charset="0"/>
-                <a:ea typeface="宋体" panose="02010600030101010101" pitchFamily="2" charset="-122"/>
+                <a:latin typeface="Arial" panose="020B0604020202090204" pitchFamily="34" charset="0"/>
+                <a:ea typeface="宋体" pitchFamily="2" charset="-122"/>
                 <a:cs typeface="+mn-cs"/>
               </a:rPr>
               <a:t>单击此处编辑母版文本样式</a:t>
@@ -1095,8 +1095,8 @@
               <a:effectLst/>
               <a:uLnTx/>
               <a:uFillTx/>
-              <a:latin typeface="Arial" panose="020B0604020202020204" pitchFamily="34" charset="0"/>
-              <a:ea typeface="宋体" panose="02010600030101010101" pitchFamily="2" charset="-122"/>
+              <a:latin typeface="Arial" panose="020B0604020202090204" pitchFamily="34" charset="0"/>
+              <a:ea typeface="宋体" pitchFamily="2" charset="-122"/>
               <a:cs typeface="+mn-cs"/>
             </a:endParaRPr>
           </a:p>
@@ -1128,8 +1128,8 @@
                 <a:effectLst/>
                 <a:uLnTx/>
                 <a:uFillTx/>
-                <a:latin typeface="Arial" panose="020B0604020202020204" pitchFamily="34" charset="0"/>
-                <a:ea typeface="宋体" panose="02010600030101010101" pitchFamily="2" charset="-122"/>
+                <a:latin typeface="Arial" panose="020B0604020202090204" pitchFamily="34" charset="0"/>
+                <a:ea typeface="宋体" pitchFamily="2" charset="-122"/>
                 <a:cs typeface="+mn-cs"/>
               </a:rPr>
               <a:t>第二级</a:t>
@@ -1144,8 +1144,8 @@
               <a:effectLst/>
               <a:uLnTx/>
               <a:uFillTx/>
-              <a:latin typeface="Arial" panose="020B0604020202020204" pitchFamily="34" charset="0"/>
-              <a:ea typeface="宋体" panose="02010600030101010101" pitchFamily="2" charset="-122"/>
+              <a:latin typeface="Arial" panose="020B0604020202090204" pitchFamily="34" charset="0"/>
+              <a:ea typeface="宋体" pitchFamily="2" charset="-122"/>
               <a:cs typeface="+mn-cs"/>
             </a:endParaRPr>
           </a:p>
@@ -1177,8 +1177,8 @@
                 <a:effectLst/>
                 <a:uLnTx/>
                 <a:uFillTx/>
-                <a:latin typeface="Arial" panose="020B0604020202020204" pitchFamily="34" charset="0"/>
-                <a:ea typeface="宋体" panose="02010600030101010101" pitchFamily="2" charset="-122"/>
+                <a:latin typeface="Arial" panose="020B0604020202090204" pitchFamily="34" charset="0"/>
+                <a:ea typeface="宋体" pitchFamily="2" charset="-122"/>
                 <a:cs typeface="+mn-cs"/>
               </a:rPr>
               <a:t>第三级</a:t>
@@ -1193,8 +1193,8 @@
               <a:effectLst/>
               <a:uLnTx/>
               <a:uFillTx/>
-              <a:latin typeface="Arial" panose="020B0604020202020204" pitchFamily="34" charset="0"/>
-              <a:ea typeface="宋体" panose="02010600030101010101" pitchFamily="2" charset="-122"/>
+              <a:latin typeface="Arial" panose="020B0604020202090204" pitchFamily="34" charset="0"/>
+              <a:ea typeface="宋体" pitchFamily="2" charset="-122"/>
               <a:cs typeface="+mn-cs"/>
             </a:endParaRPr>
           </a:p>
@@ -1226,8 +1226,8 @@
                 <a:effectLst/>
                 <a:uLnTx/>
                 <a:uFillTx/>
-                <a:latin typeface="Arial" panose="020B0604020202020204" pitchFamily="34" charset="0"/>
-                <a:ea typeface="宋体" panose="02010600030101010101" pitchFamily="2" charset="-122"/>
+                <a:latin typeface="Arial" panose="020B0604020202090204" pitchFamily="34" charset="0"/>
+                <a:ea typeface="宋体" pitchFamily="2" charset="-122"/>
                 <a:cs typeface="+mn-cs"/>
               </a:rPr>
               <a:t>第四级</a:t>
@@ -1242,8 +1242,8 @@
               <a:effectLst/>
               <a:uLnTx/>
               <a:uFillTx/>
-              <a:latin typeface="Arial" panose="020B0604020202020204" pitchFamily="34" charset="0"/>
-              <a:ea typeface="宋体" panose="02010600030101010101" pitchFamily="2" charset="-122"/>
+              <a:latin typeface="Arial" panose="020B0604020202090204" pitchFamily="34" charset="0"/>
+              <a:ea typeface="宋体" pitchFamily="2" charset="-122"/>
               <a:cs typeface="+mn-cs"/>
             </a:endParaRPr>
           </a:p>
@@ -1275,8 +1275,8 @@
                 <a:effectLst/>
                 <a:uLnTx/>
                 <a:uFillTx/>
-                <a:latin typeface="Arial" panose="020B0604020202020204" pitchFamily="34" charset="0"/>
-                <a:ea typeface="宋体" panose="02010600030101010101" pitchFamily="2" charset="-122"/>
+                <a:latin typeface="Arial" panose="020B0604020202090204" pitchFamily="34" charset="0"/>
+                <a:ea typeface="宋体" pitchFamily="2" charset="-122"/>
                 <a:cs typeface="+mn-cs"/>
               </a:rPr>
               <a:t>第五级</a:t>
@@ -1291,8 +1291,8 @@
               <a:effectLst/>
               <a:uLnTx/>
               <a:uFillTx/>
-              <a:latin typeface="Arial" panose="020B0604020202020204" pitchFamily="34" charset="0"/>
-              <a:ea typeface="宋体" panose="02010600030101010101" pitchFamily="2" charset="-122"/>
+              <a:latin typeface="Arial" panose="020B0604020202090204" pitchFamily="34" charset="0"/>
+              <a:ea typeface="宋体" pitchFamily="2" charset="-122"/>
               <a:cs typeface="+mn-cs"/>
             </a:endParaRPr>
           </a:p>
@@ -1368,7 +1368,7 @@
                 <a:solidFill>
                   <a:schemeClr val="tx1"/>
                 </a:solidFill>
-                <a:ea typeface="宋体" panose="02010600030101010101" pitchFamily="2" charset="-122"/>
+                <a:ea typeface="宋体" pitchFamily="2" charset="-122"/>
               </a:defRPr>
             </a:lvl1pPr>
           </a:lstStyle>
@@ -1399,8 +1399,8 @@
               <a:effectLst/>
               <a:uLnTx/>
               <a:uFillTx/>
-              <a:latin typeface="Arial" panose="020B0604020202020204" pitchFamily="34" charset="0"/>
-              <a:ea typeface="宋体" panose="02010600030101010101" pitchFamily="2" charset="-122"/>
+              <a:latin typeface="Arial" panose="020B0604020202090204" pitchFamily="34" charset="0"/>
+              <a:ea typeface="宋体" pitchFamily="2" charset="-122"/>
               <a:cs typeface="+mn-cs"/>
             </a:endParaRPr>
           </a:p>
@@ -1476,7 +1476,7 @@
                 <a:solidFill>
                   <a:schemeClr val="tx1"/>
                 </a:solidFill>
-                <a:ea typeface="宋体" panose="02010600030101010101" pitchFamily="2" charset="-122"/>
+                <a:ea typeface="宋体" pitchFamily="2" charset="-122"/>
               </a:defRPr>
             </a:lvl1pPr>
           </a:lstStyle>
@@ -1508,8 +1508,8 @@
                 <a:effectLst/>
                 <a:uLnTx/>
                 <a:uFillTx/>
-                <a:latin typeface="Arial" panose="020B0604020202020204" pitchFamily="34" charset="0"/>
-                <a:ea typeface="宋体" panose="02010600030101010101" pitchFamily="2" charset="-122"/>
+                <a:latin typeface="Arial" panose="020B0604020202090204" pitchFamily="34" charset="0"/>
+                <a:ea typeface="宋体" pitchFamily="2" charset="-122"/>
                 <a:cs typeface="+mn-cs"/>
               </a:rPr>
             </a:fld>
@@ -1523,8 +1523,8 @@
               <a:effectLst/>
               <a:uLnTx/>
               <a:uFillTx/>
-              <a:latin typeface="Arial" panose="020B0604020202020204" pitchFamily="34" charset="0"/>
-              <a:ea typeface="宋体" panose="02010600030101010101" pitchFamily="2" charset="-122"/>
+              <a:latin typeface="Arial" panose="020B0604020202090204" pitchFamily="34" charset="0"/>
+              <a:ea typeface="宋体" pitchFamily="2" charset="-122"/>
               <a:cs typeface="+mn-cs"/>
             </a:endParaRPr>
           </a:p>
@@ -1546,8 +1546,8 @@
         <a:solidFill>
           <a:schemeClr val="tx1"/>
         </a:solidFill>
-        <a:latin typeface="Arial" panose="020B0604020202020204" pitchFamily="34" charset="0"/>
-        <a:ea typeface="宋体" panose="02010600030101010101" pitchFamily="2" charset="-122"/>
+        <a:latin typeface="Arial" panose="020B0604020202090204" pitchFamily="34" charset="0"/>
+        <a:ea typeface="宋体" pitchFamily="2" charset="-122"/>
         <a:cs typeface="+mn-cs"/>
       </a:defRPr>
     </a:lvl1pPr>
@@ -1562,8 +1562,8 @@
         <a:solidFill>
           <a:schemeClr val="tx1"/>
         </a:solidFill>
-        <a:latin typeface="Arial" panose="020B0604020202020204" pitchFamily="34" charset="0"/>
-        <a:ea typeface="宋体" panose="02010600030101010101" pitchFamily="2" charset="-122"/>
+        <a:latin typeface="Arial" panose="020B0604020202090204" pitchFamily="34" charset="0"/>
+        <a:ea typeface="宋体" pitchFamily="2" charset="-122"/>
         <a:cs typeface="+mn-cs"/>
       </a:defRPr>
     </a:lvl2pPr>
@@ -1578,8 +1578,8 @@
         <a:solidFill>
           <a:schemeClr val="tx1"/>
         </a:solidFill>
-        <a:latin typeface="Arial" panose="020B0604020202020204" pitchFamily="34" charset="0"/>
-        <a:ea typeface="宋体" panose="02010600030101010101" pitchFamily="2" charset="-122"/>
+        <a:latin typeface="Arial" panose="020B0604020202090204" pitchFamily="34" charset="0"/>
+        <a:ea typeface="宋体" pitchFamily="2" charset="-122"/>
         <a:cs typeface="+mn-cs"/>
       </a:defRPr>
     </a:lvl3pPr>
@@ -1594,8 +1594,8 @@
         <a:solidFill>
           <a:schemeClr val="tx1"/>
         </a:solidFill>
-        <a:latin typeface="Arial" panose="020B0604020202020204" pitchFamily="34" charset="0"/>
-        <a:ea typeface="宋体" panose="02010600030101010101" pitchFamily="2" charset="-122"/>
+        <a:latin typeface="Arial" panose="020B0604020202090204" pitchFamily="34" charset="0"/>
+        <a:ea typeface="宋体" pitchFamily="2" charset="-122"/>
         <a:cs typeface="+mn-cs"/>
       </a:defRPr>
     </a:lvl4pPr>
@@ -1610,8 +1610,8 @@
         <a:solidFill>
           <a:schemeClr val="tx1"/>
         </a:solidFill>
-        <a:latin typeface="Arial" panose="020B0604020202020204" pitchFamily="34" charset="0"/>
-        <a:ea typeface="宋体" panose="02010600030101010101" pitchFamily="2" charset="-122"/>
+        <a:latin typeface="Arial" panose="020B0604020202090204" pitchFamily="34" charset="0"/>
+        <a:ea typeface="宋体" pitchFamily="2" charset="-122"/>
         <a:cs typeface="+mn-cs"/>
       </a:defRPr>
     </a:lvl5pPr>
@@ -4291,7 +4291,7 @@
                 <a:solidFill>
                   <a:srgbClr val="FF3300"/>
                 </a:solidFill>
-                <a:latin typeface="Arial" panose="020B0604020202020204" pitchFamily="34" charset="0"/>
+                <a:latin typeface="Arial" panose="020B0604020202090204" pitchFamily="34" charset="0"/>
                 <a:ea typeface="黑体" panose="02010609060101010101" pitchFamily="49" charset="-122"/>
               </a:defRPr>
             </a:lvl1pPr>
@@ -4311,7 +4311,7 @@
                 <a:solidFill>
                   <a:srgbClr val="FF3300"/>
                 </a:solidFill>
-                <a:latin typeface="Arial" panose="020B0604020202020204" pitchFamily="34" charset="0"/>
+                <a:latin typeface="Arial" panose="020B0604020202090204" pitchFamily="34" charset="0"/>
                 <a:ea typeface="黑体" panose="02010609060101010101" pitchFamily="49" charset="-122"/>
               </a:defRPr>
             </a:lvl2pPr>
@@ -4331,7 +4331,7 @@
                 <a:solidFill>
                   <a:srgbClr val="FF3300"/>
                 </a:solidFill>
-                <a:latin typeface="Arial" panose="020B0604020202020204" pitchFamily="34" charset="0"/>
+                <a:latin typeface="Arial" panose="020B0604020202090204" pitchFamily="34" charset="0"/>
                 <a:ea typeface="黑体" panose="02010609060101010101" pitchFamily="49" charset="-122"/>
               </a:defRPr>
             </a:lvl3pPr>
@@ -4351,7 +4351,7 @@
                 <a:solidFill>
                   <a:srgbClr val="FF3300"/>
                 </a:solidFill>
-                <a:latin typeface="Arial" panose="020B0604020202020204" pitchFamily="34" charset="0"/>
+                <a:latin typeface="Arial" panose="020B0604020202090204" pitchFamily="34" charset="0"/>
                 <a:ea typeface="黑体" panose="02010609060101010101" pitchFamily="49" charset="-122"/>
               </a:defRPr>
             </a:lvl4pPr>
@@ -4371,7 +4371,7 @@
                 <a:solidFill>
                   <a:srgbClr val="FF3300"/>
                 </a:solidFill>
-                <a:latin typeface="Arial" panose="020B0604020202020204" pitchFamily="34" charset="0"/>
+                <a:latin typeface="Arial" panose="020B0604020202090204" pitchFamily="34" charset="0"/>
                 <a:ea typeface="黑体" panose="02010609060101010101" pitchFamily="49" charset="-122"/>
               </a:defRPr>
             </a:lvl5pPr>
@@ -4394,7 +4394,7 @@
                 <a:solidFill>
                   <a:srgbClr val="FF3300"/>
                 </a:solidFill>
-                <a:latin typeface="Arial" panose="020B0604020202020204" pitchFamily="34" charset="0"/>
+                <a:latin typeface="Arial" panose="020B0604020202090204" pitchFamily="34" charset="0"/>
                 <a:ea typeface="黑体" panose="02010609060101010101" pitchFamily="49" charset="-122"/>
               </a:defRPr>
             </a:lvl6pPr>
@@ -4417,7 +4417,7 @@
                 <a:solidFill>
                   <a:srgbClr val="FF3300"/>
                 </a:solidFill>
-                <a:latin typeface="Arial" panose="020B0604020202020204" pitchFamily="34" charset="0"/>
+                <a:latin typeface="Arial" panose="020B0604020202090204" pitchFamily="34" charset="0"/>
                 <a:ea typeface="黑体" panose="02010609060101010101" pitchFamily="49" charset="-122"/>
               </a:defRPr>
             </a:lvl7pPr>
@@ -4440,7 +4440,7 @@
                 <a:solidFill>
                   <a:srgbClr val="FF3300"/>
                 </a:solidFill>
-                <a:latin typeface="Arial" panose="020B0604020202020204" pitchFamily="34" charset="0"/>
+                <a:latin typeface="Arial" panose="020B0604020202090204" pitchFamily="34" charset="0"/>
                 <a:ea typeface="黑体" panose="02010609060101010101" pitchFamily="49" charset="-122"/>
               </a:defRPr>
             </a:lvl8pPr>
@@ -4463,7 +4463,7 @@
                 <a:solidFill>
                   <a:srgbClr val="FF3300"/>
                 </a:solidFill>
-                <a:latin typeface="Arial" panose="020B0604020202020204" pitchFamily="34" charset="0"/>
+                <a:latin typeface="Arial" panose="020B0604020202090204" pitchFamily="34" charset="0"/>
                 <a:ea typeface="黑体" panose="02010609060101010101" pitchFamily="49" charset="-122"/>
               </a:defRPr>
             </a:lvl9pPr>
@@ -4497,7 +4497,7 @@
               <a:effectLst/>
               <a:uLnTx/>
               <a:uFillTx/>
-              <a:latin typeface="Arial" panose="020B0604020202020204" pitchFamily="34" charset="0"/>
+              <a:latin typeface="Arial" panose="020B0604020202090204" pitchFamily="34" charset="0"/>
               <a:ea typeface="黑体" panose="02010609060101010101" pitchFamily="49" charset="-122"/>
               <a:cs typeface="+mn-cs"/>
             </a:endParaRPr>
@@ -4649,8 +4649,8 @@
               <a:effectLst/>
               <a:uLnTx/>
               <a:uFillTx/>
-              <a:latin typeface="Arial" panose="020B0604020202020204" pitchFamily="34" charset="0"/>
-              <a:ea typeface="宋体" panose="02010600030101010101" pitchFamily="2" charset="-122"/>
+              <a:latin typeface="Arial" panose="020B0604020202090204" pitchFamily="34" charset="0"/>
+              <a:ea typeface="宋体" pitchFamily="2" charset="-122"/>
               <a:cs typeface="+mn-cs"/>
             </a:endParaRPr>
           </a:p>
@@ -4733,8 +4733,8 @@
               <a:effectLst/>
               <a:uLnTx/>
               <a:uFillTx/>
-              <a:latin typeface="Arial" panose="020B0604020202020204" pitchFamily="34" charset="0"/>
-              <a:ea typeface="宋体" panose="02010600030101010101" pitchFamily="2" charset="-122"/>
+              <a:latin typeface="Arial" panose="020B0604020202090204" pitchFamily="34" charset="0"/>
+              <a:ea typeface="宋体" pitchFamily="2" charset="-122"/>
               <a:cs typeface="+mn-cs"/>
             </a:endParaRPr>
           </a:p>
@@ -4818,8 +4818,8 @@
                 <a:effectLst/>
                 <a:uLnTx/>
                 <a:uFillTx/>
-                <a:latin typeface="Arial" panose="020B0604020202020204" pitchFamily="34" charset="0"/>
-                <a:ea typeface="宋体" panose="02010600030101010101" pitchFamily="2" charset="-122"/>
+                <a:latin typeface="Arial" panose="020B0604020202090204" pitchFamily="34" charset="0"/>
+                <a:ea typeface="宋体" pitchFamily="2" charset="-122"/>
                 <a:cs typeface="+mn-cs"/>
               </a:rPr>
             </a:fld>
@@ -4833,8 +4833,8 @@
               <a:effectLst/>
               <a:uLnTx/>
               <a:uFillTx/>
-              <a:latin typeface="Arial" panose="020B0604020202020204" pitchFamily="34" charset="0"/>
-              <a:ea typeface="宋体" panose="02010600030101010101" pitchFamily="2" charset="-122"/>
+              <a:latin typeface="Arial" panose="020B0604020202090204" pitchFamily="34" charset="0"/>
+              <a:ea typeface="宋体" pitchFamily="2" charset="-122"/>
               <a:cs typeface="+mn-cs"/>
             </a:endParaRPr>
           </a:p>
@@ -4989,8 +4989,8 @@
               <a:effectLst/>
               <a:uLnTx/>
               <a:uFillTx/>
-              <a:latin typeface="Arial" panose="020B0604020202020204" pitchFamily="34" charset="0"/>
-              <a:ea typeface="宋体" panose="02010600030101010101" pitchFamily="2" charset="-122"/>
+              <a:latin typeface="Arial" panose="020B0604020202090204" pitchFamily="34" charset="0"/>
+              <a:ea typeface="宋体" pitchFamily="2" charset="-122"/>
               <a:cs typeface="+mn-cs"/>
             </a:endParaRPr>
           </a:p>
@@ -5037,8 +5037,8 @@
               <a:effectLst/>
               <a:uLnTx/>
               <a:uFillTx/>
-              <a:latin typeface="Arial" panose="020B0604020202020204" pitchFamily="34" charset="0"/>
-              <a:ea typeface="宋体" panose="02010600030101010101" pitchFamily="2" charset="-122"/>
+              <a:latin typeface="Arial" panose="020B0604020202090204" pitchFamily="34" charset="0"/>
+              <a:ea typeface="宋体" pitchFamily="2" charset="-122"/>
               <a:cs typeface="+mn-cs"/>
             </a:endParaRPr>
           </a:p>
@@ -5086,8 +5086,8 @@
                 <a:effectLst/>
                 <a:uLnTx/>
                 <a:uFillTx/>
-                <a:latin typeface="Arial" panose="020B0604020202020204" pitchFamily="34" charset="0"/>
-                <a:ea typeface="宋体" panose="02010600030101010101" pitchFamily="2" charset="-122"/>
+                <a:latin typeface="Arial" panose="020B0604020202090204" pitchFamily="34" charset="0"/>
+                <a:ea typeface="宋体" pitchFamily="2" charset="-122"/>
                 <a:cs typeface="+mn-cs"/>
               </a:rPr>
             </a:fld>
@@ -5101,8 +5101,8 @@
               <a:effectLst/>
               <a:uLnTx/>
               <a:uFillTx/>
-              <a:latin typeface="Arial" panose="020B0604020202020204" pitchFamily="34" charset="0"/>
-              <a:ea typeface="宋体" panose="02010600030101010101" pitchFamily="2" charset="-122"/>
+              <a:latin typeface="Arial" panose="020B0604020202090204" pitchFamily="34" charset="0"/>
+              <a:ea typeface="宋体" pitchFamily="2" charset="-122"/>
               <a:cs typeface="+mn-cs"/>
             </a:endParaRPr>
           </a:p>
@@ -5174,8 +5174,8 @@
               <a:effectLst/>
               <a:uLnTx/>
               <a:uFillTx/>
-              <a:latin typeface="Arial" panose="020B0604020202020204" pitchFamily="34" charset="0"/>
-              <a:ea typeface="宋体" panose="02010600030101010101" pitchFamily="2" charset="-122"/>
+              <a:latin typeface="Arial" panose="020B0604020202090204" pitchFamily="34" charset="0"/>
+              <a:ea typeface="宋体" pitchFamily="2" charset="-122"/>
               <a:cs typeface="+mn-cs"/>
             </a:endParaRPr>
           </a:p>
@@ -5222,8 +5222,8 @@
               <a:effectLst/>
               <a:uLnTx/>
               <a:uFillTx/>
-              <a:latin typeface="Arial" panose="020B0604020202020204" pitchFamily="34" charset="0"/>
-              <a:ea typeface="宋体" panose="02010600030101010101" pitchFamily="2" charset="-122"/>
+              <a:latin typeface="Arial" panose="020B0604020202090204" pitchFamily="34" charset="0"/>
+              <a:ea typeface="宋体" pitchFamily="2" charset="-122"/>
               <a:cs typeface="+mn-cs"/>
             </a:endParaRPr>
           </a:p>
@@ -5271,8 +5271,8 @@
                 <a:effectLst/>
                 <a:uLnTx/>
                 <a:uFillTx/>
-                <a:latin typeface="Arial" panose="020B0604020202020204" pitchFamily="34" charset="0"/>
-                <a:ea typeface="宋体" panose="02010600030101010101" pitchFamily="2" charset="-122"/>
+                <a:latin typeface="Arial" panose="020B0604020202090204" pitchFamily="34" charset="0"/>
+                <a:ea typeface="宋体" pitchFamily="2" charset="-122"/>
                 <a:cs typeface="+mn-cs"/>
               </a:rPr>
             </a:fld>
@@ -5286,8 +5286,8 @@
               <a:effectLst/>
               <a:uLnTx/>
               <a:uFillTx/>
-              <a:latin typeface="Arial" panose="020B0604020202020204" pitchFamily="34" charset="0"/>
-              <a:ea typeface="宋体" panose="02010600030101010101" pitchFamily="2" charset="-122"/>
+              <a:latin typeface="Arial" panose="020B0604020202090204" pitchFamily="34" charset="0"/>
+              <a:ea typeface="宋体" pitchFamily="2" charset="-122"/>
               <a:cs typeface="+mn-cs"/>
             </a:endParaRPr>
           </a:p>
@@ -5573,7 +5573,7 @@
                 <a:solidFill>
                   <a:schemeClr val="tx1"/>
                 </a:solidFill>
-                <a:ea typeface="宋体" panose="02010600030101010101" pitchFamily="2" charset="-122"/>
+                <a:ea typeface="宋体" pitchFamily="2" charset="-122"/>
               </a:defRPr>
             </a:lvl1pPr>
           </a:lstStyle>
@@ -5604,8 +5604,8 @@
               <a:effectLst/>
               <a:uLnTx/>
               <a:uFillTx/>
-              <a:latin typeface="Arial" panose="020B0604020202020204" pitchFamily="34" charset="0"/>
-              <a:ea typeface="宋体" panose="02010600030101010101" pitchFamily="2" charset="-122"/>
+              <a:latin typeface="Arial" panose="020B0604020202090204" pitchFamily="34" charset="0"/>
+              <a:ea typeface="宋体" pitchFamily="2" charset="-122"/>
               <a:cs typeface="+mn-cs"/>
             </a:endParaRPr>
           </a:p>
@@ -5681,7 +5681,7 @@
                 <a:solidFill>
                   <a:schemeClr val="tx1"/>
                 </a:solidFill>
-                <a:ea typeface="宋体" panose="02010600030101010101" pitchFamily="2" charset="-122"/>
+                <a:ea typeface="宋体" pitchFamily="2" charset="-122"/>
               </a:defRPr>
             </a:lvl1pPr>
           </a:lstStyle>
@@ -5712,8 +5712,8 @@
               <a:effectLst/>
               <a:uLnTx/>
               <a:uFillTx/>
-              <a:latin typeface="Arial" panose="020B0604020202020204" pitchFamily="34" charset="0"/>
-              <a:ea typeface="宋体" panose="02010600030101010101" pitchFamily="2" charset="-122"/>
+              <a:latin typeface="Arial" panose="020B0604020202090204" pitchFamily="34" charset="0"/>
+              <a:ea typeface="宋体" pitchFamily="2" charset="-122"/>
               <a:cs typeface="+mn-cs"/>
             </a:endParaRPr>
           </a:p>
@@ -5789,7 +5789,7 @@
                 <a:solidFill>
                   <a:schemeClr val="tx1"/>
                 </a:solidFill>
-                <a:ea typeface="宋体" panose="02010600030101010101" pitchFamily="2" charset="-122"/>
+                <a:ea typeface="宋体" pitchFamily="2" charset="-122"/>
               </a:defRPr>
             </a:lvl1pPr>
           </a:lstStyle>
@@ -5821,8 +5821,8 @@
                 <a:effectLst/>
                 <a:uLnTx/>
                 <a:uFillTx/>
-                <a:latin typeface="Arial" panose="020B0604020202020204" pitchFamily="34" charset="0"/>
-                <a:ea typeface="宋体" panose="02010600030101010101" pitchFamily="2" charset="-122"/>
+                <a:latin typeface="Arial" panose="020B0604020202090204" pitchFamily="34" charset="0"/>
+                <a:ea typeface="宋体" pitchFamily="2" charset="-122"/>
                 <a:cs typeface="+mn-cs"/>
               </a:rPr>
             </a:fld>
@@ -5836,8 +5836,8 @@
               <a:effectLst/>
               <a:uLnTx/>
               <a:uFillTx/>
-              <a:latin typeface="Arial" panose="020B0604020202020204" pitchFamily="34" charset="0"/>
-              <a:ea typeface="宋体" panose="02010600030101010101" pitchFamily="2" charset="-122"/>
+              <a:latin typeface="Arial" panose="020B0604020202090204" pitchFamily="34" charset="0"/>
+              <a:ea typeface="宋体" pitchFamily="2" charset="-122"/>
               <a:cs typeface="+mn-cs"/>
             </a:endParaRPr>
           </a:p>
@@ -5915,7 +5915,7 @@
                 <a:solidFill>
                   <a:srgbClr val="FF3300"/>
                 </a:solidFill>
-                <a:latin typeface="Arial" panose="020B0604020202020204" pitchFamily="34" charset="0"/>
+                <a:latin typeface="Arial" panose="020B0604020202090204" pitchFamily="34" charset="0"/>
                 <a:ea typeface="黑体" panose="02010609060101010101" pitchFamily="49" charset="-122"/>
               </a:defRPr>
             </a:lvl1pPr>
@@ -5935,7 +5935,7 @@
                 <a:solidFill>
                   <a:srgbClr val="FF3300"/>
                 </a:solidFill>
-                <a:latin typeface="Arial" panose="020B0604020202020204" pitchFamily="34" charset="0"/>
+                <a:latin typeface="Arial" panose="020B0604020202090204" pitchFamily="34" charset="0"/>
                 <a:ea typeface="黑体" panose="02010609060101010101" pitchFamily="49" charset="-122"/>
               </a:defRPr>
             </a:lvl2pPr>
@@ -5955,7 +5955,7 @@
                 <a:solidFill>
                   <a:srgbClr val="FF3300"/>
                 </a:solidFill>
-                <a:latin typeface="Arial" panose="020B0604020202020204" pitchFamily="34" charset="0"/>
+                <a:latin typeface="Arial" panose="020B0604020202090204" pitchFamily="34" charset="0"/>
                 <a:ea typeface="黑体" panose="02010609060101010101" pitchFamily="49" charset="-122"/>
               </a:defRPr>
             </a:lvl3pPr>
@@ -5975,7 +5975,7 @@
                 <a:solidFill>
                   <a:srgbClr val="FF3300"/>
                 </a:solidFill>
-                <a:latin typeface="Arial" panose="020B0604020202020204" pitchFamily="34" charset="0"/>
+                <a:latin typeface="Arial" panose="020B0604020202090204" pitchFamily="34" charset="0"/>
                 <a:ea typeface="黑体" panose="02010609060101010101" pitchFamily="49" charset="-122"/>
               </a:defRPr>
             </a:lvl4pPr>
@@ -5995,7 +5995,7 @@
                 <a:solidFill>
                   <a:srgbClr val="FF3300"/>
                 </a:solidFill>
-                <a:latin typeface="Arial" panose="020B0604020202020204" pitchFamily="34" charset="0"/>
+                <a:latin typeface="Arial" panose="020B0604020202090204" pitchFamily="34" charset="0"/>
                 <a:ea typeface="黑体" panose="02010609060101010101" pitchFamily="49" charset="-122"/>
               </a:defRPr>
             </a:lvl5pPr>
@@ -6018,7 +6018,7 @@
                 <a:solidFill>
                   <a:srgbClr val="FF3300"/>
                 </a:solidFill>
-                <a:latin typeface="Arial" panose="020B0604020202020204" pitchFamily="34" charset="0"/>
+                <a:latin typeface="Arial" panose="020B0604020202090204" pitchFamily="34" charset="0"/>
                 <a:ea typeface="黑体" panose="02010609060101010101" pitchFamily="49" charset="-122"/>
               </a:defRPr>
             </a:lvl6pPr>
@@ -6041,7 +6041,7 @@
                 <a:solidFill>
                   <a:srgbClr val="FF3300"/>
                 </a:solidFill>
-                <a:latin typeface="Arial" panose="020B0604020202020204" pitchFamily="34" charset="0"/>
+                <a:latin typeface="Arial" panose="020B0604020202090204" pitchFamily="34" charset="0"/>
                 <a:ea typeface="黑体" panose="02010609060101010101" pitchFamily="49" charset="-122"/>
               </a:defRPr>
             </a:lvl7pPr>
@@ -6064,7 +6064,7 @@
                 <a:solidFill>
                   <a:srgbClr val="FF3300"/>
                 </a:solidFill>
-                <a:latin typeface="Arial" panose="020B0604020202020204" pitchFamily="34" charset="0"/>
+                <a:latin typeface="Arial" panose="020B0604020202090204" pitchFamily="34" charset="0"/>
                 <a:ea typeface="黑体" panose="02010609060101010101" pitchFamily="49" charset="-122"/>
               </a:defRPr>
             </a:lvl8pPr>
@@ -6087,7 +6087,7 @@
                 <a:solidFill>
                   <a:srgbClr val="FF3300"/>
                 </a:solidFill>
-                <a:latin typeface="Arial" panose="020B0604020202020204" pitchFamily="34" charset="0"/>
+                <a:latin typeface="Arial" panose="020B0604020202090204" pitchFamily="34" charset="0"/>
                 <a:ea typeface="黑体" panose="02010609060101010101" pitchFamily="49" charset="-122"/>
               </a:defRPr>
             </a:lvl9pPr>
@@ -6120,7 +6120,7 @@
               <a:uLnTx/>
               <a:uFillTx/>
               <a:latin typeface="Tahoma" panose="020B0604030504040204" pitchFamily="34" charset="0"/>
-              <a:ea typeface="宋体" panose="02010600030101010101" pitchFamily="2" charset="-122"/>
+              <a:ea typeface="宋体" pitchFamily="2" charset="-122"/>
               <a:cs typeface="+mn-cs"/>
             </a:endParaRPr>
           </a:p>
@@ -6359,7 +6359,7 @@
           <a:solidFill>
             <a:schemeClr val="tx1"/>
           </a:solidFill>
-          <a:latin typeface="Arial" panose="020B0604020202020204" pitchFamily="34" charset="0"/>
+          <a:latin typeface="Arial" panose="020B0604020202090204" pitchFamily="34" charset="0"/>
           <a:ea typeface="+mn-ea"/>
           <a:cs typeface="+mn-cs"/>
         </a:defRPr>
@@ -6379,7 +6379,7 @@
           <a:solidFill>
             <a:schemeClr val="tx1"/>
           </a:solidFill>
-          <a:latin typeface="Comic Sans MS" panose="030F0702030302020204" pitchFamily="66" charset="0"/>
+          <a:latin typeface="Comic Sans MS" panose="030F0902030302020204" pitchFamily="66" charset="0"/>
           <a:ea typeface="楷体_GB2312" pitchFamily="49" charset="-122"/>
           <a:cs typeface="+mn-cs"/>
         </a:defRPr>
@@ -6396,8 +6396,8 @@
           <a:solidFill>
             <a:schemeClr val="tx1"/>
           </a:solidFill>
-          <a:latin typeface="Arial" panose="020B0604020202020204" pitchFamily="34" charset="0"/>
-          <a:ea typeface="宋体" panose="02010600030101010101" pitchFamily="2" charset="-122"/>
+          <a:latin typeface="Arial" panose="020B0604020202090204" pitchFamily="34" charset="0"/>
+          <a:ea typeface="宋体" pitchFamily="2" charset="-122"/>
           <a:cs typeface="+mn-cs"/>
         </a:defRPr>
       </a:lvl4pPr>
@@ -6413,8 +6413,8 @@
           <a:solidFill>
             <a:schemeClr val="tx1"/>
           </a:solidFill>
-          <a:latin typeface="Arial" panose="020B0604020202020204" pitchFamily="34" charset="0"/>
-          <a:ea typeface="宋体" panose="02010600030101010101" pitchFamily="2" charset="-122"/>
+          <a:latin typeface="Arial" panose="020B0604020202090204" pitchFamily="34" charset="0"/>
+          <a:ea typeface="宋体" pitchFamily="2" charset="-122"/>
           <a:cs typeface="+mn-cs"/>
         </a:defRPr>
       </a:lvl5pPr>
@@ -6425,7 +6425,7 @@
         <a:spcBef>
           <a:spcPts val="500"/>
         </a:spcBef>
-        <a:buFont typeface="Arial" panose="020B0604020202020204" pitchFamily="34" charset="0"/>
+        <a:buFont typeface="Arial" panose="020B0604020202090204" pitchFamily="34" charset="0"/>
         <a:buChar char="•"/>
         <a:defRPr sz="1800" kern="1200">
           <a:solidFill>
@@ -6443,7 +6443,7 @@
         <a:spcBef>
           <a:spcPts val="500"/>
         </a:spcBef>
-        <a:buFont typeface="Arial" panose="020B0604020202020204" pitchFamily="34" charset="0"/>
+        <a:buFont typeface="Arial" panose="020B0604020202090204" pitchFamily="34" charset="0"/>
         <a:buChar char="•"/>
         <a:defRPr sz="1800" kern="1200">
           <a:solidFill>
@@ -6461,7 +6461,7 @@
         <a:spcBef>
           <a:spcPts val="500"/>
         </a:spcBef>
-        <a:buFont typeface="Arial" panose="020B0604020202020204" pitchFamily="34" charset="0"/>
+        <a:buFont typeface="Arial" panose="020B0604020202090204" pitchFamily="34" charset="0"/>
         <a:buChar char="•"/>
         <a:defRPr sz="1800" kern="1200">
           <a:solidFill>
@@ -6479,7 +6479,7 @@
         <a:spcBef>
           <a:spcPts val="500"/>
         </a:spcBef>
-        <a:buFont typeface="Arial" panose="020B0604020202020204" pitchFamily="34" charset="0"/>
+        <a:buFont typeface="Arial" panose="020B0604020202090204" pitchFamily="34" charset="0"/>
         <a:buChar char="•"/>
         <a:defRPr sz="1800" kern="1200">
           <a:solidFill>
@@ -6786,8 +6786,8 @@
         </p:nvSpPr>
         <p:spPr>
           <a:xfrm>
-            <a:off x="438912" y="1052703"/>
-            <a:ext cx="8321040" cy="502920"/>
+            <a:off x="438912" y="1066356"/>
+            <a:ext cx="8321040" cy="475615"/>
           </a:xfrm>
           <a:prstGeom prst="rect">
             <a:avLst/>
@@ -6808,7 +6808,7 @@
                 </a:solidFill>
                 <a:latin typeface="微软雅黑" panose="020B0503020204020204" charset="-122"/>
               </a:rPr>
-              <a:t>实验组织逻辑：围绕四个研究假设展开</a:t>
+              <a:t>实验组织：围绕四个研究假设展开</a:t>
             </a:r>
             <a:endParaRPr sz="2500" b="1">
               <a:solidFill>
@@ -17893,7 +17893,7 @@
         <p:spPr>
           <a:xfrm>
             <a:off x="594360" y="1234440"/>
-            <a:ext cx="3749039" cy="3840480"/>
+            <a:ext cx="3825875" cy="3840480"/>
           </a:xfrm>
           <a:prstGeom prst="rect">
             <a:avLst/>
@@ -17984,7 +17984,7 @@
         </p:nvSpPr>
         <p:spPr>
           <a:xfrm>
-            <a:off x="841248" y="1965960"/>
+            <a:off x="683133" y="1965960"/>
             <a:ext cx="7863840" cy="1097280"/>
           </a:xfrm>
           <a:prstGeom prst="rect">
@@ -18147,7 +18147,7 @@
         </p:nvSpPr>
         <p:spPr>
           <a:xfrm>
-            <a:off x="4956048" y="1965960"/>
+            <a:off x="4787773" y="1965960"/>
             <a:ext cx="7863840" cy="1097280"/>
           </a:xfrm>
           <a:prstGeom prst="rect">
@@ -18259,7 +18259,7 @@
                 </a:solidFill>
                 <a:latin typeface="微软雅黑" panose="020B0503020204020204" charset="-122"/>
               </a:rPr>
-              <a:t>结论口径：SQL+ 的阶段性价值主要在 repairability，而不是初次生成成本</a:t>
+              <a:t>结论：SQL+ 的阶段性价值主要在 repairability，而不是初次生成成本</a:t>
             </a:r>
             <a:endParaRPr sz="1200" b="1">
               <a:solidFill>
@@ -19477,7 +19477,7 @@
 </file>
 
 <file path=ppt/slides/slide25.xml><?xml version="1.0" encoding="utf-8"?>
-<p:sld xmlns:a="http://schemas.openxmlformats.org/drawingml/2006/main" xmlns:r="http://schemas.openxmlformats.org/officeDocument/2006/relationships" xmlns:p="http://schemas.openxmlformats.org/presentationml/2006/main">
+<p:sld xmlns:a="http://schemas.openxmlformats.org/drawingml/2006/main" xmlns:r="http://schemas.openxmlformats.org/officeDocument/2006/relationships" xmlns:p="http://schemas.openxmlformats.org/presentationml/2006/main" show="0">
   <p:cSld>
     <p:spTree>
       <p:nvGrpSpPr>
@@ -20094,71 +20094,12 @@
           </a:p>
         </p:txBody>
       </p:sp>
-      <p:sp>
-        <p:nvSpPr>
-          <p:cNvPr id="17" name="Rectangle 16"/>
-          <p:cNvSpPr/>
-          <p:nvPr/>
-        </p:nvSpPr>
-        <p:spPr>
-          <a:xfrm>
-            <a:off x="914400" y="5257800"/>
-            <a:ext cx="7315200" cy="475488"/>
-          </a:xfrm>
-          <a:prstGeom prst="rect">
-            <a:avLst/>
-          </a:prstGeom>
-          <a:solidFill>
-            <a:srgbClr val="EEF2F7"/>
-          </a:solidFill>
-          <a:ln>
-            <a:solidFill>
-              <a:srgbClr val="AA3C3C"/>
-            </a:solidFill>
-          </a:ln>
-        </p:spPr>
-        <p:style>
-          <a:lnRef idx="1">
-            <a:schemeClr val="accent1"/>
-          </a:lnRef>
-          <a:fillRef idx="3">
-            <a:schemeClr val="accent1"/>
-          </a:fillRef>
-          <a:effectRef idx="2">
-            <a:schemeClr val="accent1"/>
-          </a:effectRef>
-          <a:fontRef idx="minor">
-            <a:schemeClr val="lt1"/>
-          </a:fontRef>
-        </p:style>
-        <p:txBody>
-          <a:bodyPr wrap="square" rtlCol="0" anchor="ctr"/>
-          <a:lstStyle/>
-          <a:p>
-            <a:pPr algn="ctr"/>
-            <a:r>
-              <a:rPr sz="1200" b="1">
-                <a:solidFill>
-                  <a:srgbClr val="2D2D2D"/>
-                </a:solidFill>
-                <a:latin typeface="微软雅黑" panose="020B0503020204020204" charset="-122"/>
-              </a:rPr>
-              <a:t>表述边界：强调“尝试结合”，不使用“首创”或“显著领先”等过强说法</a:t>
-            </a:r>
-            <a:endParaRPr sz="1200" b="1">
-              <a:solidFill>
-                <a:srgbClr val="2D2D2D"/>
-              </a:solidFill>
-              <a:latin typeface="微软雅黑" panose="020B0503020204020204" charset="-122"/>
-            </a:endParaRPr>
-          </a:p>
-        </p:txBody>
-      </p:sp>
     </p:spTree>
   </p:cSld>
   <p:clrMapOvr>
     <a:masterClrMapping/>
   </p:clrMapOvr>
+  <p:transition/>
 </p:sld>
 </file>
 
@@ -21171,7 +21112,7 @@
         </p:nvSpPr>
         <p:spPr>
           <a:xfrm>
-            <a:off x="502920" y="6428232"/>
+            <a:off x="-24765" y="7207377"/>
             <a:ext cx="8138160" cy="201168"/>
           </a:xfrm>
           <a:prstGeom prst="rect">
@@ -21206,58 +21147,13 @@
       </p:sp>
       <p:sp>
         <p:nvSpPr>
-          <p:cNvPr id="4" name="Rectangle 3"/>
-          <p:cNvSpPr/>
-          <p:nvPr/>
-        </p:nvSpPr>
-        <p:spPr>
-          <a:xfrm>
-            <a:off x="347472" y="987552"/>
-            <a:ext cx="8458200" cy="5321808"/>
-          </a:xfrm>
-          <a:prstGeom prst="rect">
-            <a:avLst/>
-          </a:prstGeom>
-          <a:solidFill>
-            <a:srgbClr val="FFFFFF"/>
-          </a:solidFill>
-          <a:ln>
-            <a:solidFill>
-              <a:srgbClr val="FFFFFF"/>
-            </a:solidFill>
-          </a:ln>
-        </p:spPr>
-        <p:style>
-          <a:lnRef idx="1">
-            <a:schemeClr val="accent1"/>
-          </a:lnRef>
-          <a:fillRef idx="3">
-            <a:schemeClr val="accent1"/>
-          </a:fillRef>
-          <a:effectRef idx="2">
-            <a:schemeClr val="accent1"/>
-          </a:effectRef>
-          <a:fontRef idx="minor">
-            <a:schemeClr val="lt1"/>
-          </a:fontRef>
-        </p:style>
-        <p:txBody>
-          <a:bodyPr rtlCol="0" anchor="ctr"/>
-          <a:lstStyle/>
-          <a:p>
-            <a:pPr algn="ctr"/>
-          </a:p>
-        </p:txBody>
-      </p:sp>
-      <p:sp>
-        <p:nvSpPr>
           <p:cNvPr id="5" name="Rectangle 4"/>
           <p:cNvSpPr/>
           <p:nvPr/>
         </p:nvSpPr>
         <p:spPr>
           <a:xfrm>
-            <a:off x="914400" y="1325880"/>
+            <a:off x="467995" y="1916430"/>
             <a:ext cx="7315200" cy="868680"/>
           </a:xfrm>
           <a:prstGeom prst="rect">
@@ -21308,7 +21204,7 @@
         </p:nvSpPr>
         <p:spPr>
           <a:xfrm>
-            <a:off x="1143000" y="1508760"/>
+            <a:off x="696595" y="2099310"/>
             <a:ext cx="1234440" cy="320040"/>
           </a:xfrm>
           <a:prstGeom prst="rect">
@@ -21349,7 +21245,7 @@
         </p:nvSpPr>
         <p:spPr>
           <a:xfrm>
-            <a:off x="2606040" y="1508760"/>
+            <a:off x="2159635" y="2099310"/>
             <a:ext cx="5212080" cy="384048"/>
           </a:xfrm>
           <a:prstGeom prst="rect">
@@ -21390,7 +21286,7 @@
         </p:nvSpPr>
         <p:spPr>
           <a:xfrm>
-            <a:off x="914400" y="2651760"/>
+            <a:off x="467995" y="3242310"/>
             <a:ext cx="7315200" cy="868680"/>
           </a:xfrm>
           <a:prstGeom prst="rect">
@@ -21441,7 +21337,7 @@
         </p:nvSpPr>
         <p:spPr>
           <a:xfrm>
-            <a:off x="1143000" y="2834640"/>
+            <a:off x="696595" y="3425190"/>
             <a:ext cx="1234440" cy="320040"/>
           </a:xfrm>
           <a:prstGeom prst="rect">
@@ -21482,7 +21378,7 @@
         </p:nvSpPr>
         <p:spPr>
           <a:xfrm>
-            <a:off x="2606040" y="2834640"/>
+            <a:off x="2159635" y="3425190"/>
             <a:ext cx="5212080" cy="384048"/>
           </a:xfrm>
           <a:prstGeom prst="rect">
@@ -21523,7 +21419,7 @@
         </p:nvSpPr>
         <p:spPr>
           <a:xfrm>
-            <a:off x="914400" y="3977639"/>
+            <a:off x="467995" y="4568189"/>
             <a:ext cx="7315200" cy="868680"/>
           </a:xfrm>
           <a:prstGeom prst="rect">
@@ -21574,7 +21470,7 @@
         </p:nvSpPr>
         <p:spPr>
           <a:xfrm>
-            <a:off x="1143000" y="4160520"/>
+            <a:off x="696595" y="4751070"/>
             <a:ext cx="1234440" cy="320040"/>
           </a:xfrm>
           <a:prstGeom prst="rect">
@@ -21615,7 +21511,7 @@
         </p:nvSpPr>
         <p:spPr>
           <a:xfrm>
-            <a:off x="2606040" y="4160520"/>
+            <a:off x="2159635" y="4751070"/>
             <a:ext cx="5212080" cy="384048"/>
           </a:xfrm>
           <a:prstGeom prst="rect">
@@ -21709,58 +21605,13 @@
       </p:sp>
       <p:sp>
         <p:nvSpPr>
-          <p:cNvPr id="4" name="Rectangle 3"/>
-          <p:cNvSpPr/>
-          <p:nvPr/>
-        </p:nvSpPr>
-        <p:spPr>
-          <a:xfrm>
-            <a:off x="347472" y="987552"/>
-            <a:ext cx="8458200" cy="5321808"/>
-          </a:xfrm>
-          <a:prstGeom prst="rect">
-            <a:avLst/>
-          </a:prstGeom>
-          <a:solidFill>
-            <a:srgbClr val="FFFFFF"/>
-          </a:solidFill>
-          <a:ln>
-            <a:solidFill>
-              <a:srgbClr val="FFFFFF"/>
-            </a:solidFill>
-          </a:ln>
-        </p:spPr>
-        <p:style>
-          <a:lnRef idx="1">
-            <a:schemeClr val="accent1"/>
-          </a:lnRef>
-          <a:fillRef idx="3">
-            <a:schemeClr val="accent1"/>
-          </a:fillRef>
-          <a:effectRef idx="2">
-            <a:schemeClr val="accent1"/>
-          </a:effectRef>
-          <a:fontRef idx="minor">
-            <a:schemeClr val="lt1"/>
-          </a:fontRef>
-        </p:style>
-        <p:txBody>
-          <a:bodyPr rtlCol="0" anchor="ctr"/>
-          <a:lstStyle/>
-          <a:p>
-            <a:pPr algn="ctr"/>
-          </a:p>
-        </p:txBody>
-      </p:sp>
-      <p:sp>
-        <p:nvSpPr>
           <p:cNvPr id="5" name="Rectangle 4"/>
           <p:cNvSpPr/>
           <p:nvPr/>
         </p:nvSpPr>
         <p:spPr>
           <a:xfrm>
-            <a:off x="685800" y="1417320"/>
+            <a:off x="438785" y="1872615"/>
             <a:ext cx="3429000" cy="1234440"/>
           </a:xfrm>
           <a:prstGeom prst="rect">
@@ -21811,7 +21662,7 @@
         </p:nvSpPr>
         <p:spPr>
           <a:xfrm>
-            <a:off x="886968" y="1600200"/>
+            <a:off x="639953" y="2055495"/>
             <a:ext cx="2743200" cy="256032"/>
           </a:xfrm>
           <a:prstGeom prst="rect">
@@ -21852,7 +21703,7 @@
         </p:nvSpPr>
         <p:spPr>
           <a:xfrm>
-            <a:off x="886968" y="1947672"/>
+            <a:off x="639953" y="2402967"/>
             <a:ext cx="2743200" cy="502920"/>
           </a:xfrm>
           <a:prstGeom prst="rect">
@@ -21895,7 +21746,7 @@
         </p:nvSpPr>
         <p:spPr>
           <a:xfrm>
-            <a:off x="4617720" y="1417320"/>
+            <a:off x="4370705" y="1872615"/>
             <a:ext cx="3429000" cy="1234440"/>
           </a:xfrm>
           <a:prstGeom prst="rect">
@@ -21946,7 +21797,7 @@
         </p:nvSpPr>
         <p:spPr>
           <a:xfrm>
-            <a:off x="4818888" y="1600200"/>
+            <a:off x="4571873" y="2055495"/>
             <a:ext cx="2743200" cy="256032"/>
           </a:xfrm>
           <a:prstGeom prst="rect">
@@ -21987,7 +21838,7 @@
         </p:nvSpPr>
         <p:spPr>
           <a:xfrm>
-            <a:off x="4818888" y="1947672"/>
+            <a:off x="4571873" y="2402967"/>
             <a:ext cx="2743200" cy="502920"/>
           </a:xfrm>
           <a:prstGeom prst="rect">
@@ -22030,7 +21881,7 @@
         </p:nvSpPr>
         <p:spPr>
           <a:xfrm>
-            <a:off x="685800" y="3154680"/>
+            <a:off x="438785" y="3609975"/>
             <a:ext cx="3429000" cy="1234440"/>
           </a:xfrm>
           <a:prstGeom prst="rect">
@@ -22081,7 +21932,7 @@
         </p:nvSpPr>
         <p:spPr>
           <a:xfrm>
-            <a:off x="886968" y="3337560"/>
+            <a:off x="639953" y="3792855"/>
             <a:ext cx="2743200" cy="256032"/>
           </a:xfrm>
           <a:prstGeom prst="rect">
@@ -22122,7 +21973,7 @@
         </p:nvSpPr>
         <p:spPr>
           <a:xfrm>
-            <a:off x="886968" y="3685032"/>
+            <a:off x="639953" y="4140327"/>
             <a:ext cx="2743200" cy="502920"/>
           </a:xfrm>
           <a:prstGeom prst="rect">
@@ -22166,7 +22017,7 @@
         </p:nvSpPr>
         <p:spPr>
           <a:xfrm>
-            <a:off x="4617720" y="3154680"/>
+            <a:off x="4370705" y="3609975"/>
             <a:ext cx="3429000" cy="1234440"/>
           </a:xfrm>
           <a:prstGeom prst="rect">
@@ -22217,7 +22068,7 @@
         </p:nvSpPr>
         <p:spPr>
           <a:xfrm>
-            <a:off x="4818888" y="3337560"/>
+            <a:off x="4571873" y="3792855"/>
             <a:ext cx="2743200" cy="256032"/>
           </a:xfrm>
           <a:prstGeom prst="rect">
@@ -22258,7 +22109,7 @@
         </p:nvSpPr>
         <p:spPr>
           <a:xfrm>
-            <a:off x="4818888" y="3685032"/>
+            <a:off x="4571873" y="4140327"/>
             <a:ext cx="2743200" cy="502920"/>
           </a:xfrm>
           <a:prstGeom prst="rect">
@@ -23041,11 +22892,11 @@
           </a:bodyPr>
           <a:lstStyle/>
           <a:p>
-            <a:pPr marL="285750" indent="-285750">
+            <a:pPr marL="285750" indent="-285750" hangingPunct="1">
               <a:spcAft>
                 <a:spcPts val="700"/>
               </a:spcAft>
-              <a:buFont typeface="Arial" panose="020B0604020202020204" pitchFamily="34" charset="0"/>
+              <a:buFont typeface="Arial" panose="020B0604020202090204" pitchFamily="34" charset="0"/>
               <a:buChar char="•"/>
               <a:defRPr sz="1500">
                 <a:solidFill>
@@ -23059,11 +22910,11 @@
             </a:r>
           </a:p>
           <a:p>
-            <a:pPr marL="285750" indent="-285750">
+            <a:pPr marL="285750" indent="-285750" hangingPunct="1">
               <a:spcAft>
                 <a:spcPts val="700"/>
               </a:spcAft>
-              <a:buFont typeface="Arial" panose="020B0604020202020204" pitchFamily="34" charset="0"/>
+              <a:buFont typeface="Arial" panose="020B0604020202090204" pitchFamily="34" charset="0"/>
               <a:buChar char="•"/>
               <a:defRPr sz="1500">
                 <a:solidFill>
@@ -23077,11 +22928,11 @@
             </a:r>
           </a:p>
           <a:p>
-            <a:pPr marL="285750" indent="-285750">
+            <a:pPr marL="285750" indent="-285750" hangingPunct="1">
               <a:spcAft>
                 <a:spcPts val="700"/>
               </a:spcAft>
-              <a:buFont typeface="Arial" panose="020B0604020202020204" pitchFamily="34" charset="0"/>
+              <a:buFont typeface="Arial" panose="020B0604020202090204" pitchFamily="34" charset="0"/>
               <a:buChar char="•"/>
               <a:defRPr sz="1500">
                 <a:solidFill>
@@ -23853,58 +23704,13 @@
       </p:sp>
       <p:sp>
         <p:nvSpPr>
-          <p:cNvPr id="4" name="Rectangle 3"/>
-          <p:cNvSpPr/>
-          <p:nvPr/>
-        </p:nvSpPr>
-        <p:spPr>
-          <a:xfrm>
-            <a:off x="347472" y="987552"/>
-            <a:ext cx="8458200" cy="5321808"/>
-          </a:xfrm>
-          <a:prstGeom prst="rect">
-            <a:avLst/>
-          </a:prstGeom>
-          <a:solidFill>
-            <a:srgbClr val="FFFFFF"/>
-          </a:solidFill>
-          <a:ln>
-            <a:solidFill>
-              <a:srgbClr val="FFFFFF"/>
-            </a:solidFill>
-          </a:ln>
-        </p:spPr>
-        <p:style>
-          <a:lnRef idx="1">
-            <a:schemeClr val="accent1"/>
-          </a:lnRef>
-          <a:fillRef idx="3">
-            <a:schemeClr val="accent1"/>
-          </a:fillRef>
-          <a:effectRef idx="2">
-            <a:schemeClr val="accent1"/>
-          </a:effectRef>
-          <a:fontRef idx="minor">
-            <a:schemeClr val="lt1"/>
-          </a:fontRef>
-        </p:style>
-        <p:txBody>
-          <a:bodyPr rtlCol="0" anchor="ctr"/>
-          <a:lstStyle/>
-          <a:p>
-            <a:pPr algn="ctr"/>
-          </a:p>
-        </p:txBody>
-      </p:sp>
-      <p:sp>
-        <p:nvSpPr>
           <p:cNvPr id="5" name="Rectangle 4"/>
           <p:cNvSpPr/>
           <p:nvPr/>
         </p:nvSpPr>
         <p:spPr>
           <a:xfrm>
-            <a:off x="594360" y="1508760"/>
+            <a:off x="446405" y="1952625"/>
             <a:ext cx="1627632" cy="1874519"/>
           </a:xfrm>
           <a:prstGeom prst="rect">
@@ -23955,7 +23761,7 @@
         </p:nvSpPr>
         <p:spPr>
           <a:xfrm>
-            <a:off x="749808" y="1719072"/>
+            <a:off x="601853" y="2162937"/>
             <a:ext cx="1280160" cy="274320"/>
           </a:xfrm>
           <a:prstGeom prst="rect">
@@ -23996,7 +23802,7 @@
         </p:nvSpPr>
         <p:spPr>
           <a:xfrm>
-            <a:off x="758952" y="2212848"/>
+            <a:off x="610997" y="2656713"/>
             <a:ext cx="1225296" cy="822960"/>
           </a:xfrm>
           <a:prstGeom prst="rect">
@@ -24039,7 +23845,7 @@
         </p:nvSpPr>
         <p:spPr>
           <a:xfrm>
-            <a:off x="2295144" y="2267712"/>
+            <a:off x="2147189" y="2711577"/>
             <a:ext cx="320040" cy="219456"/>
           </a:xfrm>
           <a:prstGeom prst="rect">
@@ -24080,7 +23886,7 @@
         </p:nvSpPr>
         <p:spPr>
           <a:xfrm>
-            <a:off x="2651760" y="1508760"/>
+            <a:off x="2503805" y="1952625"/>
             <a:ext cx="1627632" cy="1874519"/>
           </a:xfrm>
           <a:prstGeom prst="rect">
@@ -24131,7 +23937,7 @@
         </p:nvSpPr>
         <p:spPr>
           <a:xfrm>
-            <a:off x="2807208" y="1719072"/>
+            <a:off x="2659253" y="2162937"/>
             <a:ext cx="1280160" cy="274320"/>
           </a:xfrm>
           <a:prstGeom prst="rect">
@@ -24172,7 +23978,7 @@
         </p:nvSpPr>
         <p:spPr>
           <a:xfrm>
-            <a:off x="2816352" y="2212848"/>
+            <a:off x="2668397" y="2656713"/>
             <a:ext cx="1225296" cy="822960"/>
           </a:xfrm>
           <a:prstGeom prst="rect">
@@ -24215,7 +24021,7 @@
         </p:nvSpPr>
         <p:spPr>
           <a:xfrm>
-            <a:off x="4352544" y="2267712"/>
+            <a:off x="4204589" y="2711577"/>
             <a:ext cx="320040" cy="219456"/>
           </a:xfrm>
           <a:prstGeom prst="rect">
@@ -24256,7 +24062,7 @@
         </p:nvSpPr>
         <p:spPr>
           <a:xfrm>
-            <a:off x="4709160" y="1508760"/>
+            <a:off x="4561205" y="1952625"/>
             <a:ext cx="1627632" cy="1874519"/>
           </a:xfrm>
           <a:prstGeom prst="rect">
@@ -24307,7 +24113,7 @@
         </p:nvSpPr>
         <p:spPr>
           <a:xfrm>
-            <a:off x="4864608" y="1719072"/>
+            <a:off x="4716653" y="2162937"/>
             <a:ext cx="1280160" cy="274320"/>
           </a:xfrm>
           <a:prstGeom prst="rect">
@@ -24348,7 +24154,7 @@
         </p:nvSpPr>
         <p:spPr>
           <a:xfrm>
-            <a:off x="4873752" y="2212848"/>
+            <a:off x="4725797" y="2656713"/>
             <a:ext cx="1225296" cy="822960"/>
           </a:xfrm>
           <a:prstGeom prst="rect">
@@ -24391,7 +24197,7 @@
         </p:nvSpPr>
         <p:spPr>
           <a:xfrm>
-            <a:off x="6409944" y="2267712"/>
+            <a:off x="6261989" y="2711577"/>
             <a:ext cx="320040" cy="219456"/>
           </a:xfrm>
           <a:prstGeom prst="rect">
@@ -24432,7 +24238,7 @@
         </p:nvSpPr>
         <p:spPr>
           <a:xfrm>
-            <a:off x="6766560" y="1508760"/>
+            <a:off x="6618605" y="1952625"/>
             <a:ext cx="1627632" cy="1874519"/>
           </a:xfrm>
           <a:prstGeom prst="rect">
@@ -24483,7 +24289,7 @@
         </p:nvSpPr>
         <p:spPr>
           <a:xfrm>
-            <a:off x="6922008" y="1719072"/>
+            <a:off x="6774053" y="2162937"/>
             <a:ext cx="1280160" cy="274320"/>
           </a:xfrm>
           <a:prstGeom prst="rect">
@@ -24524,7 +24330,7 @@
         </p:nvSpPr>
         <p:spPr>
           <a:xfrm>
-            <a:off x="6931152" y="2212848"/>
+            <a:off x="6783197" y="2656713"/>
             <a:ext cx="1225296" cy="822960"/>
           </a:xfrm>
           <a:prstGeom prst="rect">
@@ -24567,7 +24373,7 @@
         </p:nvSpPr>
         <p:spPr>
           <a:xfrm>
-            <a:off x="822960" y="4343400"/>
+            <a:off x="601980" y="4220845"/>
             <a:ext cx="7498080" cy="1270635"/>
           </a:xfrm>
           <a:prstGeom prst="rect">
@@ -28926,7 +28732,7 @@
               <a:srgbClr val="FF3300"/>
             </a:solidFill>
             <a:effectLst/>
-            <a:latin typeface="Arial" panose="020B0604020202020204" pitchFamily="34" charset="0"/>
+            <a:latin typeface="Arial" panose="020B0604020202090204" pitchFamily="34" charset="0"/>
             <a:ea typeface="黑体" panose="02010609060101010101" pitchFamily="49" charset="-122"/>
           </a:defRPr>
         </a:defPPr>
@@ -28986,7 +28792,7 @@
               <a:srgbClr val="FF3300"/>
             </a:solidFill>
             <a:effectLst/>
-            <a:latin typeface="Arial" panose="020B0604020202020204" pitchFamily="34" charset="0"/>
+            <a:latin typeface="Arial" panose="020B0604020202090204" pitchFamily="34" charset="0"/>
             <a:ea typeface="黑体" panose="02010609060101010101" pitchFamily="49" charset="-122"/>
           </a:defRPr>
         </a:defPPr>

</xml_diff>